<commit_message>
Update: Entlastungsbetrag 125€ → 131€ (Pflegereform 2025) in allen Artikeln, Investor-Seiten und Pitch Deck
</commit_message>
<xml_diff>
--- a/Alltagsengel_Pitch_Deck_2026.pptx
+++ b/Alltagsengel_Pitch_Deck_2026.pptx
@@ -4613,7 +4613,7 @@
                 <a:ea typeface="Georgia" pitchFamily="34" charset="-122"/>
                 <a:cs typeface="Georgia" pitchFamily="34" charset="-120"/>
               </a:rPr>
-              <a:t>125€</a:t>
+              <a:t>131€</a:t>
             </a:r>
             <a:endParaRPr lang="en-US" sz="6400" dirty="0"/>
           </a:p>
@@ -7045,7 +7045,7 @@
                 <a:ea typeface="Calibri" pitchFamily="34" charset="-122"/>
                 <a:cs typeface="Calibri" pitchFamily="34" charset="-120"/>
               </a:rPr>
-              <a:t>125€/Monat</a:t>
+              <a:t>131€/Monat</a:t>
             </a:r>
             <a:endParaRPr lang="en-US" sz="1400" dirty="0"/>
           </a:p>

</xml_diff>